<commit_message>
Recolour the mock report and slide decks with phd_ui colours
Drive the mock deliverables from the phd_ui scheme instead of ad-hoc hexes:
ink for the header band and body text, orange as the accent, grey for text
bars / rules, sand for subtle page and figure fills, and blue/orange/green
scheme hues (rippled via create_saturation_palette) for the figure slots.

Co-Authored-By: Claude Opus 4.8 <noreply@anthropic.com>
</commit_message>
<xml_diff>
--- a/docs/mock_slides_16x9.pptx
+++ b/docs/mock_slides_16x9.pptx
@@ -3106,7 +3106,7 @@
             <a:avLst/>
           </a:prstGeom>
           <a:solidFill>
-            <a:srgbClr val="2F3B52"/>
+            <a:srgbClr val="1D1A16"/>
           </a:solidFill>
           <a:ln>
             <a:noFill/>
@@ -3150,7 +3150,7 @@
             <a:avLst/>
           </a:prstGeom>
           <a:solidFill>
-            <a:srgbClr val="E07B39"/>
+            <a:srgbClr val="D55B2A"/>
           </a:solidFill>
           <a:ln>
             <a:noFill/>
@@ -3255,7 +3255,7 @@
             <a:avLst/>
           </a:prstGeom>
           <a:solidFill>
-            <a:srgbClr val="2F3B52"/>
+            <a:srgbClr val="1D1A16"/>
           </a:solidFill>
           <a:ln>
             <a:noFill/>
@@ -3307,7 +3307,7 @@
             <a:avLst/>
           </a:prstGeom>
           <a:solidFill>
-            <a:srgbClr val="E07B39"/>
+            <a:srgbClr val="D55B2A"/>
           </a:solidFill>
           <a:ln>
             <a:noFill/>
@@ -3385,7 +3385,7 @@
             <a:r>
               <a:rPr sz="1100" i="1">
                 <a:solidFill>
-                  <a:srgbClr val="555555"/>
+                  <a:srgbClr val="413B34"/>
                 </a:solidFill>
               </a:rPr>
               <a:t>slide_16x9  (26 x 14 cm)</a:t>
@@ -3426,7 +3426,7 @@
             <a:avLst/>
           </a:prstGeom>
           <a:solidFill>
-            <a:srgbClr val="2F3B52"/>
+            <a:srgbClr val="1D1A16"/>
           </a:solidFill>
           <a:ln>
             <a:noFill/>
@@ -3478,7 +3478,7 @@
             <a:avLst/>
           </a:prstGeom>
           <a:solidFill>
-            <a:srgbClr val="E07B39"/>
+            <a:srgbClr val="D55B2A"/>
           </a:solidFill>
           <a:ln>
             <a:noFill/>
@@ -3556,7 +3556,7 @@
             <a:r>
               <a:rPr sz="1100" i="1">
                 <a:solidFill>
-                  <a:srgbClr val="555555"/>
+                  <a:srgbClr val="413B34"/>
                 </a:solidFill>
               </a:rPr>
               <a:t>slide_half  (14.5 x 12 cm)</a:t>
@@ -3613,7 +3613,7 @@
             <a:r>
               <a:rPr sz="1100" i="1">
                 <a:solidFill>
-                  <a:srgbClr val="555555"/>
+                  <a:srgbClr val="413B34"/>
                 </a:solidFill>
               </a:rPr>
               <a:t>slide_half  (14.5 x 12 cm)</a:t>
@@ -3654,7 +3654,7 @@
             <a:avLst/>
           </a:prstGeom>
           <a:solidFill>
-            <a:srgbClr val="2F3B52"/>
+            <a:srgbClr val="1D1A16"/>
           </a:solidFill>
           <a:ln>
             <a:noFill/>
@@ -3706,7 +3706,7 @@
             <a:avLst/>
           </a:prstGeom>
           <a:solidFill>
-            <a:srgbClr val="E07B39"/>
+            <a:srgbClr val="D55B2A"/>
           </a:solidFill>
           <a:ln>
             <a:noFill/>
@@ -3765,7 +3765,7 @@
             <a:r>
               <a:rPr sz="1500">
                 <a:solidFill>
-                  <a:srgbClr val="2F3B52"/>
+                  <a:srgbClr val="1D1A16"/>
                 </a:solidFill>
               </a:rPr>
               <a:t>•  Conversion rises with temperature</a:t>
@@ -3780,7 +3780,7 @@
             <a:r>
               <a:rPr sz="1500">
                 <a:solidFill>
-                  <a:srgbClr val="2F3B52"/>
+                  <a:srgbClr val="1D1A16"/>
                 </a:solidFill>
               </a:rPr>
               <a:t>•  Selectivity peaks near 250 C</a:t>
@@ -3795,7 +3795,7 @@
             <a:r>
               <a:rPr sz="1500">
                 <a:solidFill>
-                  <a:srgbClr val="2F3B52"/>
+                  <a:srgbClr val="1D1A16"/>
                 </a:solidFill>
               </a:rPr>
               <a:t>•  Model matches the measured trend</a:t>

</xml_diff>